<commit_message>
Deck: add 'Changes Since Last Review' slide; cite simple M2 metrics
Co-Authored-By: Claude Opus 4.8 (1M context) <noreply@anthropic.com>
</commit_message>
<xml_diff>
--- a/reports/Meta_Labeling_Deck.pptx
+++ b/reports/Meta_Labeling_Deck.pptx
@@ -17,6 +17,7 @@
     <p:sldId id="265" r:id="rId16"/>
     <p:sldId id="266" r:id="rId17"/>
     <p:sldId id="267" r:id="rId18"/>
+    <p:sldId id="268" r:id="rId19"/>
   </p:sldIdLst>
   <p:sldSz cx="12191695" cy="6858000" type="screen4x3"/>
   <p:notesSz cx="6858000" cy="9144000"/>
@@ -3344,7 +3345,7 @@
               </a:defRPr>
             </a:pPr>
             <a:r>
-              <a:t>Attribution — Factors &amp; Costs</a:t>
+              <a:t>Key Finding — M2 Does Not Add Value Yet</a:t>
             </a:r>
           </a:p>
         </p:txBody>
@@ -3426,7 +3427,7 @@
               </a:defRPr>
             </a:pPr>
             <a:r>
-              <a:t>■  M1 decomposed into its two sub-signals (full-sample Sharpe):</a:t>
+              <a:t>■  M2's probabilities carry no information — realized success is flat across every predicted bucket:</a:t>
             </a:r>
           </a:p>
           <a:p>
@@ -3441,7 +3442,7 @@
               </a:defRPr>
             </a:pPr>
             <a:r>
-              <a:t>–  momentum 0.61  ·  trend 0.65  ·  combined technical 0.65</a:t>
+              <a:t>–  predicted 0.14 → realized 0.44   |   predicted 0.82 → realized 0.43</a:t>
             </a:r>
           </a:p>
           <a:p>
@@ -3456,7 +3457,22 @@
               </a:defRPr>
             </a:pPr>
             <a:r>
-              <a:t>■  Interaction is positive (+0.015) — momentum and trend reinforce, not redundant.</a:t>
+              <a:t>■  AUC-ROC = 0.50 full / 0.46 out-of-sample — i.e. random, slightly worse OOS.</a:t>
+            </a:r>
+          </a:p>
+          <a:p>
+            <a:pPr lvl="1">
+              <a:spcAft>
+                <a:spcPts val="500"/>
+              </a:spcAft>
+              <a:defRPr sz="1400" b="0">
+                <a:solidFill>
+                  <a:srgbClr val="555B66"/>
+                </a:solidFill>
+              </a:defRPr>
+            </a:pPr>
+            <a:r>
+              <a:t>–  Simple error metrics agree — Brier 0.31, calibration MAPE ≈ 0.49 (probabilities ~49% off).</a:t>
             </a:r>
           </a:p>
           <a:p>
@@ -3471,22 +3487,22 @@
               </a:defRPr>
             </a:pPr>
             <a:r>
-              <a:t>■  Cost layers (annualized): gross 6.48% → net of expense 6.39% → net of all 6.19%.</a:t>
-            </a:r>
-          </a:p>
-          <a:p>
-            <a:pPr lvl="1">
+              <a:t>■  M2 underperforms M1-only in every walk-forward window.</a:t>
+            </a:r>
+          </a:p>
+          <a:p>
+            <a:pPr>
               <a:spcAft>
                 <a:spcPts val="500"/>
               </a:spcAft>
-              <a:defRPr sz="1400" b="0">
-                <a:solidFill>
-                  <a:srgbClr val="555B66"/>
+              <a:defRPr sz="1700" b="1">
+                <a:solidFill>
+                  <a:srgbClr val="0B2A4A"/>
                 </a:solidFill>
               </a:defRPr>
             </a:pPr>
             <a:r>
-              <a:t>–  transaction cost (~29 bps) is a larger drag than the expense ratio (~9 bps)</a:t>
+              <a:t>■  Held under both proxy and real macro data — robust, not a tuning artifact.</a:t>
             </a:r>
           </a:p>
         </p:txBody>
@@ -3565,7 +3581,7 @@
               </a:defRPr>
             </a:pPr>
             <a:r>
-              <a:t>Takeaway:  The directional value is real and complementary; costs are modest and turnover-driven.</a:t>
+              <a:t>Takeaway:  The meta-label as specified (per-asset, 4-week, benchmark-relative) extracts no conditional signal.</a:t>
             </a:r>
           </a:p>
         </p:txBody>
@@ -3732,7 +3748,7 @@
               </a:defRPr>
             </a:pPr>
             <a:r>
-              <a:t>Limitations</a:t>
+              <a:t>Attribution — Factors &amp; Costs</a:t>
             </a:r>
           </a:p>
         </p:txBody>
@@ -3814,7 +3830,22 @@
               </a:defRPr>
             </a:pPr>
             <a:r>
-              <a:t>■  Research-grade data (free index / ETF-proxy series); true long-history index needs Bloomberg.</a:t>
+              <a:t>■  M1 decomposed into its two sub-signals (full-sample Sharpe):</a:t>
+            </a:r>
+          </a:p>
+          <a:p>
+            <a:pPr lvl="1">
+              <a:spcAft>
+                <a:spcPts val="500"/>
+              </a:spcAft>
+              <a:defRPr sz="1400" b="0">
+                <a:solidFill>
+                  <a:srgbClr val="555B66"/>
+                </a:solidFill>
+              </a:defRPr>
+            </a:pPr>
+            <a:r>
+              <a:t>–  momentum 0.61  ·  trend 0.65  ·  combined technical 0.65</a:t>
             </a:r>
           </a:p>
           <a:p>
@@ -3829,7 +3860,7 @@
               </a:defRPr>
             </a:pPr>
             <a:r>
-              <a:t>■  Historical simulation only — no capacity, market impact, borrow, or live execution.</a:t>
+              <a:t>■  Interaction is positive (+0.015) — momentum and trend reinforce, not redundant.</a:t>
             </a:r>
           </a:p>
           <a:p>
@@ -3844,37 +3875,22 @@
               </a:defRPr>
             </a:pPr>
             <a:r>
-              <a:t>■  M1's edge is regime-concentrated (recent), not uniform across history.</a:t>
-            </a:r>
-          </a:p>
-          <a:p>
-            <a:pPr>
+              <a:t>■  Cost layers (annualized): gross 6.48% → net of expense 6.39% → net of all 6.19%.</a:t>
+            </a:r>
+          </a:p>
+          <a:p>
+            <a:pPr lvl="1">
               <a:spcAft>
                 <a:spcPts val="500"/>
               </a:spcAft>
-              <a:defRPr sz="1700" b="1">
-                <a:solidFill>
-                  <a:srgbClr val="0B2A4A"/>
+              <a:defRPr sz="1400" b="0">
+                <a:solidFill>
+                  <a:srgbClr val="555B66"/>
                 </a:solidFill>
               </a:defRPr>
             </a:pPr>
             <a:r>
-              <a:t>■  M2 is not yet usable; its prediction target needs reformulation.</a:t>
-            </a:r>
-          </a:p>
-          <a:p>
-            <a:pPr>
-              <a:spcAft>
-                <a:spcPts val="500"/>
-              </a:spcAft>
-              <a:defRPr sz="1700" b="1">
-                <a:solidFill>
-                  <a:srgbClr val="0B2A4A"/>
-                </a:solidFill>
-              </a:defRPr>
-            </a:pPr>
-            <a:r>
-              <a:t>■  Some diagnostics are full-sample; production needs broader walk-forward / purged CV.</a:t>
+              <a:t>–  transaction cost (~29 bps) is a larger drag than the expense ratio (~9 bps)</a:t>
             </a:r>
           </a:p>
         </p:txBody>
@@ -3953,7 +3969,7 @@
               </a:defRPr>
             </a:pPr>
             <a:r>
-              <a:t>Takeaway:  Solid on each step — we report what works and what does not, without overselling.</a:t>
+              <a:t>Takeaway:  The directional value is real and complementary; costs are modest and turnover-driven.</a:t>
             </a:r>
           </a:p>
         </p:txBody>
@@ -4120,7 +4136,7 @@
               </a:defRPr>
             </a:pPr>
             <a:r>
-              <a:t>Questions for Discussion</a:t>
+              <a:t>Limitations</a:t>
             </a:r>
           </a:p>
         </p:txBody>
@@ -4202,37 +4218,7 @@
               </a:defRPr>
             </a:pPr>
             <a:r>
-              <a:t>■  M2 reformulation — which direction?</a:t>
-            </a:r>
-          </a:p>
-          <a:p>
-            <a:pPr lvl="1">
-              <a:spcAft>
-                <a:spcPts val="500"/>
-              </a:spcAft>
-              <a:defRPr sz="1400" b="0">
-                <a:solidFill>
-                  <a:srgbClr val="555B66"/>
-                </a:solidFill>
-              </a:defRPr>
-            </a:pPr>
-            <a:r>
-              <a:t>–  a regime gate (scale total active risk down in stress), or</a:t>
-            </a:r>
-          </a:p>
-          <a:p>
-            <a:pPr lvl="1">
-              <a:spcAft>
-                <a:spcPts val="500"/>
-              </a:spcAft>
-              <a:defRPr sz="1400" b="0">
-                <a:solidFill>
-                  <a:srgbClr val="555B66"/>
-                </a:solidFill>
-              </a:defRPr>
-            </a:pPr>
-            <a:r>
-              <a:t>–  a factor-timer (momentum vs trend by regime), or a different target / horizon?</a:t>
+              <a:t>■  Research-grade data (free index / ETF-proxy series); true long-history index needs Bloomberg.</a:t>
             </a:r>
           </a:p>
           <a:p>
@@ -4247,7 +4233,7 @@
               </a:defRPr>
             </a:pPr>
             <a:r>
-              <a:t>■  Is the 4-week, benchmark-relative success label the right thing to predict?</a:t>
+              <a:t>■  Historical simulation only — no capacity, market impact, borrow, or live execution.</a:t>
             </a:r>
           </a:p>
           <a:p>
@@ -4262,7 +4248,7 @@
               </a:defRPr>
             </a:pPr>
             <a:r>
-              <a:t>■  M1's edge is recent-regime concentrated — acceptable, or do we need cross-regime robustness?</a:t>
+              <a:t>■  M1's edge is regime-concentrated (recent), not uniform across history.</a:t>
             </a:r>
           </a:p>
           <a:p>
@@ -4277,7 +4263,7 @@
               </a:defRPr>
             </a:pPr>
             <a:r>
-              <a:t>■  Data — prioritize Bloomberg true-index history (pre-2012)? Which sleeves first?</a:t>
+              <a:t>■  M2 is not yet usable; its prediction target needs reformulation.</a:t>
             </a:r>
           </a:p>
           <a:p>
@@ -4292,22 +4278,7 @@
               </a:defRPr>
             </a:pPr>
             <a:r>
-              <a:t>■  Universe — stay at 7, or add IG credit + broad commodity (9)?</a:t>
-            </a:r>
-          </a:p>
-          <a:p>
-            <a:pPr>
-              <a:spcAft>
-                <a:spcPts val="500"/>
-              </a:spcAft>
-              <a:defRPr sz="1700" b="1">
-                <a:solidFill>
-                  <a:srgbClr val="0B2A4A"/>
-                </a:solidFill>
-              </a:defRPr>
-            </a:pPr>
-            <a:r>
-              <a:t>■  Benchmark / tracking-error budget for the information-ratio framing?</a:t>
+              <a:t>■  Some diagnostics are full-sample; production needs broader walk-forward / purged CV.</a:t>
             </a:r>
           </a:p>
         </p:txBody>
@@ -4386,7 +4357,7 @@
               </a:defRPr>
             </a:pPr>
             <a:r>
-              <a:t>Takeaway:  We are solid on M1 and the framework; M2's design is the open research decision.</a:t>
+              <a:t>Takeaway:  Solid on each step — we report what works and what does not, without overselling.</a:t>
             </a:r>
           </a:p>
         </p:txBody>
@@ -4457,6 +4428,439 @@
             </a:pPr>
             <a:r>
               <a:t>11</a:t>
+            </a:r>
+          </a:p>
+        </p:txBody>
+      </p:sp>
+    </p:spTree>
+  </p:cSld>
+  <p:clrMapOvr>
+    <a:masterClrMapping/>
+  </p:clrMapOvr>
+</p:sld>
+</file>
+
+<file path=ppt/slides/slide13.xml><?xml version="1.0" encoding="utf-8"?>
+<p:sld xmlns:a="http://schemas.openxmlformats.org/drawingml/2006/main" xmlns:p="http://schemas.openxmlformats.org/presentationml/2006/main" xmlns:r="http://schemas.openxmlformats.org/officeDocument/2006/relationships">
+  <p:cSld>
+    <p:spTree>
+      <p:nvGrpSpPr>
+        <p:cNvPr id="1" name=""/>
+        <p:cNvGrpSpPr/>
+        <p:nvPr/>
+      </p:nvGrpSpPr>
+      <p:grpSpPr/>
+      <p:sp>
+        <p:nvSpPr>
+          <p:cNvPr id="2" name="Rectangle 1"/>
+          <p:cNvSpPr/>
+          <p:nvPr/>
+        </p:nvSpPr>
+        <p:spPr>
+          <a:xfrm>
+            <a:off x="0" y="0"/>
+            <a:ext cx="201168" cy="6858000"/>
+          </a:xfrm>
+          <a:prstGeom prst="rect">
+            <a:avLst/>
+          </a:prstGeom>
+          <a:solidFill>
+            <a:srgbClr val="0B2A4A"/>
+          </a:solidFill>
+          <a:ln>
+            <a:noFill/>
+          </a:ln>
+          <a:effectLst/>
+        </p:spPr>
+        <p:style>
+          <a:lnRef idx="1">
+            <a:schemeClr val="accent1"/>
+          </a:lnRef>
+          <a:fillRef idx="3">
+            <a:schemeClr val="accent1"/>
+          </a:fillRef>
+          <a:effectRef idx="2">
+            <a:schemeClr val="accent1"/>
+          </a:effectRef>
+          <a:fontRef idx="minor">
+            <a:schemeClr val="lt1"/>
+          </a:fontRef>
+        </p:style>
+        <p:txBody>
+          <a:bodyPr rtlCol="0" anchor="ctr"/>
+          <a:lstStyle/>
+          <a:p>
+            <a:pPr algn="ctr"/>
+          </a:p>
+        </p:txBody>
+      </p:sp>
+      <p:sp>
+        <p:nvSpPr>
+          <p:cNvPr id="3" name="TextBox 2"/>
+          <p:cNvSpPr txBox="1"/>
+          <p:nvPr/>
+        </p:nvSpPr>
+        <p:spPr>
+          <a:xfrm>
+            <a:off x="548640" y="320040"/>
+            <a:ext cx="11338560" cy="822960"/>
+          </a:xfrm>
+          <a:prstGeom prst="rect">
+            <a:avLst/>
+          </a:prstGeom>
+          <a:noFill/>
+        </p:spPr>
+        <p:txBody>
+          <a:bodyPr wrap="square">
+            <a:spAutoFit/>
+          </a:bodyPr>
+          <a:lstStyle/>
+          <a:p>
+            <a:pPr>
+              <a:defRPr sz="2600" b="1">
+                <a:solidFill>
+                  <a:srgbClr val="0B2A4A"/>
+                </a:solidFill>
+              </a:defRPr>
+            </a:pPr>
+            <a:r>
+              <a:t>Questions for Discussion</a:t>
+            </a:r>
+          </a:p>
+        </p:txBody>
+      </p:sp>
+      <p:sp>
+        <p:nvSpPr>
+          <p:cNvPr id="4" name="Rectangle 3"/>
+          <p:cNvSpPr/>
+          <p:nvPr/>
+        </p:nvSpPr>
+        <p:spPr>
+          <a:xfrm>
+            <a:off x="566928" y="1078992"/>
+            <a:ext cx="3840480" cy="41148"/>
+          </a:xfrm>
+          <a:prstGeom prst="rect">
+            <a:avLst/>
+          </a:prstGeom>
+          <a:solidFill>
+            <a:srgbClr val="1F6FB2"/>
+          </a:solidFill>
+          <a:ln>
+            <a:noFill/>
+          </a:ln>
+          <a:effectLst/>
+        </p:spPr>
+        <p:style>
+          <a:lnRef idx="1">
+            <a:schemeClr val="accent1"/>
+          </a:lnRef>
+          <a:fillRef idx="3">
+            <a:schemeClr val="accent1"/>
+          </a:fillRef>
+          <a:effectRef idx="2">
+            <a:schemeClr val="accent1"/>
+          </a:effectRef>
+          <a:fontRef idx="minor">
+            <a:schemeClr val="lt1"/>
+          </a:fontRef>
+        </p:style>
+        <p:txBody>
+          <a:bodyPr rtlCol="0" anchor="ctr"/>
+          <a:lstStyle/>
+          <a:p>
+            <a:pPr algn="ctr"/>
+          </a:p>
+        </p:txBody>
+      </p:sp>
+      <p:sp>
+        <p:nvSpPr>
+          <p:cNvPr id="5" name="TextBox 4"/>
+          <p:cNvSpPr txBox="1"/>
+          <p:nvPr/>
+        </p:nvSpPr>
+        <p:spPr>
+          <a:xfrm>
+            <a:off x="640080" y="1325880"/>
+            <a:ext cx="10972800" cy="4297680"/>
+          </a:xfrm>
+          <a:prstGeom prst="rect">
+            <a:avLst/>
+          </a:prstGeom>
+          <a:noFill/>
+        </p:spPr>
+        <p:txBody>
+          <a:bodyPr wrap="square">
+            <a:spAutoFit/>
+          </a:bodyPr>
+          <a:lstStyle/>
+          <a:p>
+            <a:pPr>
+              <a:spcAft>
+                <a:spcPts val="500"/>
+              </a:spcAft>
+              <a:defRPr sz="1700" b="1">
+                <a:solidFill>
+                  <a:srgbClr val="0B2A4A"/>
+                </a:solidFill>
+              </a:defRPr>
+            </a:pPr>
+            <a:r>
+              <a:t>■  M2 reformulation — which direction?</a:t>
+            </a:r>
+          </a:p>
+          <a:p>
+            <a:pPr lvl="1">
+              <a:spcAft>
+                <a:spcPts val="500"/>
+              </a:spcAft>
+              <a:defRPr sz="1400" b="0">
+                <a:solidFill>
+                  <a:srgbClr val="555B66"/>
+                </a:solidFill>
+              </a:defRPr>
+            </a:pPr>
+            <a:r>
+              <a:t>–  a regime gate (scale total active risk down in stress), or</a:t>
+            </a:r>
+          </a:p>
+          <a:p>
+            <a:pPr lvl="1">
+              <a:spcAft>
+                <a:spcPts val="500"/>
+              </a:spcAft>
+              <a:defRPr sz="1400" b="0">
+                <a:solidFill>
+                  <a:srgbClr val="555B66"/>
+                </a:solidFill>
+              </a:defRPr>
+            </a:pPr>
+            <a:r>
+              <a:t>–  a factor-timer (momentum vs trend by regime), or a different target / horizon?</a:t>
+            </a:r>
+          </a:p>
+          <a:p>
+            <a:pPr>
+              <a:spcAft>
+                <a:spcPts val="500"/>
+              </a:spcAft>
+              <a:defRPr sz="1700" b="1">
+                <a:solidFill>
+                  <a:srgbClr val="0B2A4A"/>
+                </a:solidFill>
+              </a:defRPr>
+            </a:pPr>
+            <a:r>
+              <a:t>■  Is the 4-week, benchmark-relative success label the right thing to predict?</a:t>
+            </a:r>
+          </a:p>
+          <a:p>
+            <a:pPr>
+              <a:spcAft>
+                <a:spcPts val="500"/>
+              </a:spcAft>
+              <a:defRPr sz="1700" b="1">
+                <a:solidFill>
+                  <a:srgbClr val="0B2A4A"/>
+                </a:solidFill>
+              </a:defRPr>
+            </a:pPr>
+            <a:r>
+              <a:t>■  M1's edge is recent-regime concentrated — acceptable, or do we need cross-regime robustness?</a:t>
+            </a:r>
+          </a:p>
+          <a:p>
+            <a:pPr>
+              <a:spcAft>
+                <a:spcPts val="500"/>
+              </a:spcAft>
+              <a:defRPr sz="1700" b="1">
+                <a:solidFill>
+                  <a:srgbClr val="0B2A4A"/>
+                </a:solidFill>
+              </a:defRPr>
+            </a:pPr>
+            <a:r>
+              <a:t>■  Data — prioritize Bloomberg true-index history (pre-2012)? Which sleeves first?</a:t>
+            </a:r>
+          </a:p>
+          <a:p>
+            <a:pPr>
+              <a:spcAft>
+                <a:spcPts val="500"/>
+              </a:spcAft>
+              <a:defRPr sz="1700" b="1">
+                <a:solidFill>
+                  <a:srgbClr val="0B2A4A"/>
+                </a:solidFill>
+              </a:defRPr>
+            </a:pPr>
+            <a:r>
+              <a:t>■  Universe — stay at 7, or add IG credit + broad commodity (9)?</a:t>
+            </a:r>
+          </a:p>
+          <a:p>
+            <a:pPr>
+              <a:spcAft>
+                <a:spcPts val="500"/>
+              </a:spcAft>
+              <a:defRPr sz="1700" b="1">
+                <a:solidFill>
+                  <a:srgbClr val="0B2A4A"/>
+                </a:solidFill>
+              </a:defRPr>
+            </a:pPr>
+            <a:r>
+              <a:t>■  Benchmark / tracking-error budget for the information-ratio framing?</a:t>
+            </a:r>
+          </a:p>
+        </p:txBody>
+      </p:sp>
+      <p:sp>
+        <p:nvSpPr>
+          <p:cNvPr id="6" name="Rectangle 5"/>
+          <p:cNvSpPr/>
+          <p:nvPr/>
+        </p:nvSpPr>
+        <p:spPr>
+          <a:xfrm>
+            <a:off x="548640" y="5715000"/>
+            <a:ext cx="11091672" cy="566928"/>
+          </a:xfrm>
+          <a:prstGeom prst="rect">
+            <a:avLst/>
+          </a:prstGeom>
+          <a:solidFill>
+            <a:srgbClr val="ECF1F6"/>
+          </a:solidFill>
+          <a:ln>
+            <a:noFill/>
+          </a:ln>
+          <a:effectLst/>
+        </p:spPr>
+        <p:style>
+          <a:lnRef idx="1">
+            <a:schemeClr val="accent1"/>
+          </a:lnRef>
+          <a:fillRef idx="3">
+            <a:schemeClr val="accent1"/>
+          </a:fillRef>
+          <a:effectRef idx="2">
+            <a:schemeClr val="accent1"/>
+          </a:effectRef>
+          <a:fontRef idx="minor">
+            <a:schemeClr val="lt1"/>
+          </a:fontRef>
+        </p:style>
+        <p:txBody>
+          <a:bodyPr rtlCol="0" anchor="ctr"/>
+          <a:lstStyle/>
+          <a:p>
+            <a:pPr algn="ctr"/>
+          </a:p>
+        </p:txBody>
+      </p:sp>
+      <p:sp>
+        <p:nvSpPr>
+          <p:cNvPr id="7" name="TextBox 6"/>
+          <p:cNvSpPr txBox="1"/>
+          <p:nvPr/>
+        </p:nvSpPr>
+        <p:spPr>
+          <a:xfrm>
+            <a:off x="731520" y="5760720"/>
+            <a:ext cx="10789920" cy="502920"/>
+          </a:xfrm>
+          <a:prstGeom prst="rect">
+            <a:avLst/>
+          </a:prstGeom>
+          <a:noFill/>
+        </p:spPr>
+        <p:txBody>
+          <a:bodyPr wrap="square" anchor="ctr">
+            <a:spAutoFit/>
+          </a:bodyPr>
+          <a:lstStyle/>
+          <a:p>
+            <a:pPr>
+              <a:defRPr sz="1300" b="1">
+                <a:solidFill>
+                  <a:srgbClr val="1F6FB2"/>
+                </a:solidFill>
+              </a:defRPr>
+            </a:pPr>
+            <a:r>
+              <a:t>Takeaway:  We are solid on M1 and the framework; M2's design is the open research decision.</a:t>
+            </a:r>
+          </a:p>
+        </p:txBody>
+      </p:sp>
+      <p:sp>
+        <p:nvSpPr>
+          <p:cNvPr id="8" name="TextBox 7"/>
+          <p:cNvSpPr txBox="1"/>
+          <p:nvPr/>
+        </p:nvSpPr>
+        <p:spPr>
+          <a:xfrm>
+            <a:off x="548640" y="6419088"/>
+            <a:ext cx="11155680" cy="320040"/>
+          </a:xfrm>
+          <a:prstGeom prst="rect">
+            <a:avLst/>
+          </a:prstGeom>
+          <a:noFill/>
+        </p:spPr>
+        <p:txBody>
+          <a:bodyPr wrap="square">
+            <a:spAutoFit/>
+          </a:bodyPr>
+          <a:lstStyle/>
+          <a:p>
+            <a:pPr>
+              <a:defRPr sz="900">
+                <a:solidFill>
+                  <a:srgbClr val="555B66"/>
+                </a:solidFill>
+              </a:defRPr>
+            </a:pPr>
+            <a:r>
+              <a:t>Multi-Asset Meta-Labeling  ·  June 18, 2026</a:t>
+            </a:r>
+          </a:p>
+        </p:txBody>
+      </p:sp>
+      <p:sp>
+        <p:nvSpPr>
+          <p:cNvPr id="9" name="TextBox 8"/>
+          <p:cNvSpPr txBox="1"/>
+          <p:nvPr/>
+        </p:nvSpPr>
+        <p:spPr>
+          <a:xfrm>
+            <a:off x="11338560" y="6419088"/>
+            <a:ext cx="640080" cy="320040"/>
+          </a:xfrm>
+          <a:prstGeom prst="rect">
+            <a:avLst/>
+          </a:prstGeom>
+          <a:noFill/>
+        </p:spPr>
+        <p:txBody>
+          <a:bodyPr wrap="square">
+            <a:spAutoFit/>
+          </a:bodyPr>
+          <a:lstStyle/>
+          <a:p>
+            <a:pPr>
+              <a:defRPr sz="900">
+                <a:solidFill>
+                  <a:srgbClr val="555B66"/>
+                </a:solidFill>
+              </a:defRPr>
+            </a:pPr>
+            <a:r>
+              <a:t>12</a:t>
             </a:r>
           </a:p>
         </p:txBody>
@@ -4956,7 +5360,7 @@
               </a:defRPr>
             </a:pPr>
             <a:r>
-              <a:t>Architecture</a:t>
+              <a:t>Changes Since Last Review</a:t>
             </a:r>
           </a:p>
         </p:txBody>
@@ -5038,7 +5442,7 @@
               </a:defRPr>
             </a:pPr>
             <a:r>
-              <a:t>■  M1 — static, linear directional model (momentum + trend only).</a:t>
+              <a:t>■  M1 simplified to a single static factor (momentum + trend); macro &amp; risk moved out.</a:t>
             </a:r>
           </a:p>
           <a:p>
@@ -5053,37 +5457,7 @@
               </a:defRPr>
             </a:pPr>
             <a:r>
-              <a:t>■  M2 — dynamic, regime-aware meta-label (logistic regression):</a:t>
-            </a:r>
-          </a:p>
-          <a:p>
-            <a:pPr lvl="1">
-              <a:spcAft>
-                <a:spcPts val="500"/>
-              </a:spcAft>
-              <a:defRPr sz="1400" b="0">
-                <a:solidFill>
-                  <a:srgbClr val="555B66"/>
-                </a:solidFill>
-              </a:defRPr>
-            </a:pPr>
-            <a:r>
-              <a:t>–  sees momentum, trend, macro, volatility separately + regime features</a:t>
-            </a:r>
-          </a:p>
-          <a:p>
-            <a:pPr lvl="1">
-              <a:spcAft>
-                <a:spcPts val="500"/>
-              </a:spcAft>
-              <a:defRPr sz="1400" b="0">
-                <a:solidFill>
-                  <a:srgbClr val="555B66"/>
-                </a:solidFill>
-              </a:defRPr>
-            </a:pPr>
-            <a:r>
-              <a:t>–  weights factors differently across regimes (factor-timing)</a:t>
+              <a:t>■  ML layer kept to logistic regression only.</a:t>
             </a:r>
           </a:p>
           <a:p>
@@ -5098,7 +5472,7 @@
               </a:defRPr>
             </a:pPr>
             <a:r>
-              <a:t>■  Portfolio — benchmark-relative active weights, vol targeting, position caps, 2-layer costs.</a:t>
+              <a:t>■  Static factors → M1; dynamic factors (macro, volatility, regime) → M2.</a:t>
             </a:r>
           </a:p>
           <a:p>
@@ -5113,7 +5487,37 @@
               </a:defRPr>
             </a:pPr>
             <a:r>
-              <a:t>■  Discipline — no look-ahead, 4-week macro lag, 4-week train/test embargo.</a:t>
+              <a:t>■  Macro / regime datasets now feed M2 (not used by earlier work).</a:t>
+            </a:r>
+          </a:p>
+          <a:p>
+            <a:pPr>
+              <a:spcAft>
+                <a:spcPts val="500"/>
+              </a:spcAft>
+              <a:defRPr sz="1700" b="1">
+                <a:solidFill>
+                  <a:srgbClr val="0B2A4A"/>
+                </a:solidFill>
+              </a:defRPr>
+            </a:pPr>
+            <a:r>
+              <a:t>■  Added simple evaluations — mean difference, MAE, Brier, calibration MAPE.</a:t>
+            </a:r>
+          </a:p>
+          <a:p>
+            <a:pPr>
+              <a:spcAft>
+                <a:spcPts val="500"/>
+              </a:spcAft>
+              <a:defRPr sz="1700" b="1">
+                <a:solidFill>
+                  <a:srgbClr val="0B2A4A"/>
+                </a:solidFill>
+              </a:defRPr>
+            </a:pPr>
+            <a:r>
+              <a:t>■  Out-of-sample confirmation — train/test split + 4-week embargo + walk-forward.</a:t>
             </a:r>
           </a:p>
         </p:txBody>
@@ -5192,7 +5596,7 @@
               </a:defRPr>
             </a:pPr>
             <a:r>
-              <a:t>Takeaway:  M1 is simple on purpose; all dynamic / regime intelligence is isolated in M2.</a:t>
+              <a:t>Takeaway:  Every change follows one rule: static -&gt; M1, dynamic -&gt; M2, keep each layer simple.</a:t>
             </a:r>
           </a:p>
         </p:txBody>
@@ -5276,6 +5680,409 @@
 </file>
 
 <file path=ppt/slides/slide4.xml><?xml version="1.0" encoding="utf-8"?>
+<p:sld xmlns:a="http://schemas.openxmlformats.org/drawingml/2006/main" xmlns:p="http://schemas.openxmlformats.org/presentationml/2006/main" xmlns:r="http://schemas.openxmlformats.org/officeDocument/2006/relationships">
+  <p:cSld>
+    <p:spTree>
+      <p:nvGrpSpPr>
+        <p:cNvPr id="1" name=""/>
+        <p:cNvGrpSpPr/>
+        <p:nvPr/>
+      </p:nvGrpSpPr>
+      <p:grpSpPr/>
+      <p:sp>
+        <p:nvSpPr>
+          <p:cNvPr id="2" name="Rectangle 1"/>
+          <p:cNvSpPr/>
+          <p:nvPr/>
+        </p:nvSpPr>
+        <p:spPr>
+          <a:xfrm>
+            <a:off x="0" y="0"/>
+            <a:ext cx="201168" cy="6858000"/>
+          </a:xfrm>
+          <a:prstGeom prst="rect">
+            <a:avLst/>
+          </a:prstGeom>
+          <a:solidFill>
+            <a:srgbClr val="0B2A4A"/>
+          </a:solidFill>
+          <a:ln>
+            <a:noFill/>
+          </a:ln>
+          <a:effectLst/>
+        </p:spPr>
+        <p:style>
+          <a:lnRef idx="1">
+            <a:schemeClr val="accent1"/>
+          </a:lnRef>
+          <a:fillRef idx="3">
+            <a:schemeClr val="accent1"/>
+          </a:fillRef>
+          <a:effectRef idx="2">
+            <a:schemeClr val="accent1"/>
+          </a:effectRef>
+          <a:fontRef idx="minor">
+            <a:schemeClr val="lt1"/>
+          </a:fontRef>
+        </p:style>
+        <p:txBody>
+          <a:bodyPr rtlCol="0" anchor="ctr"/>
+          <a:lstStyle/>
+          <a:p>
+            <a:pPr algn="ctr"/>
+          </a:p>
+        </p:txBody>
+      </p:sp>
+      <p:sp>
+        <p:nvSpPr>
+          <p:cNvPr id="3" name="TextBox 2"/>
+          <p:cNvSpPr txBox="1"/>
+          <p:nvPr/>
+        </p:nvSpPr>
+        <p:spPr>
+          <a:xfrm>
+            <a:off x="548640" y="320040"/>
+            <a:ext cx="11338560" cy="822960"/>
+          </a:xfrm>
+          <a:prstGeom prst="rect">
+            <a:avLst/>
+          </a:prstGeom>
+          <a:noFill/>
+        </p:spPr>
+        <p:txBody>
+          <a:bodyPr wrap="square">
+            <a:spAutoFit/>
+          </a:bodyPr>
+          <a:lstStyle/>
+          <a:p>
+            <a:pPr>
+              <a:defRPr sz="2600" b="1">
+                <a:solidFill>
+                  <a:srgbClr val="0B2A4A"/>
+                </a:solidFill>
+              </a:defRPr>
+            </a:pPr>
+            <a:r>
+              <a:t>Architecture</a:t>
+            </a:r>
+          </a:p>
+        </p:txBody>
+      </p:sp>
+      <p:sp>
+        <p:nvSpPr>
+          <p:cNvPr id="4" name="Rectangle 3"/>
+          <p:cNvSpPr/>
+          <p:nvPr/>
+        </p:nvSpPr>
+        <p:spPr>
+          <a:xfrm>
+            <a:off x="566928" y="1078992"/>
+            <a:ext cx="3840480" cy="41148"/>
+          </a:xfrm>
+          <a:prstGeom prst="rect">
+            <a:avLst/>
+          </a:prstGeom>
+          <a:solidFill>
+            <a:srgbClr val="1F6FB2"/>
+          </a:solidFill>
+          <a:ln>
+            <a:noFill/>
+          </a:ln>
+          <a:effectLst/>
+        </p:spPr>
+        <p:style>
+          <a:lnRef idx="1">
+            <a:schemeClr val="accent1"/>
+          </a:lnRef>
+          <a:fillRef idx="3">
+            <a:schemeClr val="accent1"/>
+          </a:fillRef>
+          <a:effectRef idx="2">
+            <a:schemeClr val="accent1"/>
+          </a:effectRef>
+          <a:fontRef idx="minor">
+            <a:schemeClr val="lt1"/>
+          </a:fontRef>
+        </p:style>
+        <p:txBody>
+          <a:bodyPr rtlCol="0" anchor="ctr"/>
+          <a:lstStyle/>
+          <a:p>
+            <a:pPr algn="ctr"/>
+          </a:p>
+        </p:txBody>
+      </p:sp>
+      <p:sp>
+        <p:nvSpPr>
+          <p:cNvPr id="5" name="TextBox 4"/>
+          <p:cNvSpPr txBox="1"/>
+          <p:nvPr/>
+        </p:nvSpPr>
+        <p:spPr>
+          <a:xfrm>
+            <a:off x="640080" y="1325880"/>
+            <a:ext cx="10972800" cy="4297680"/>
+          </a:xfrm>
+          <a:prstGeom prst="rect">
+            <a:avLst/>
+          </a:prstGeom>
+          <a:noFill/>
+        </p:spPr>
+        <p:txBody>
+          <a:bodyPr wrap="square">
+            <a:spAutoFit/>
+          </a:bodyPr>
+          <a:lstStyle/>
+          <a:p>
+            <a:pPr>
+              <a:spcAft>
+                <a:spcPts val="500"/>
+              </a:spcAft>
+              <a:defRPr sz="1700" b="1">
+                <a:solidFill>
+                  <a:srgbClr val="0B2A4A"/>
+                </a:solidFill>
+              </a:defRPr>
+            </a:pPr>
+            <a:r>
+              <a:t>■  M1 — static, linear directional model (momentum + trend only).</a:t>
+            </a:r>
+          </a:p>
+          <a:p>
+            <a:pPr>
+              <a:spcAft>
+                <a:spcPts val="500"/>
+              </a:spcAft>
+              <a:defRPr sz="1700" b="1">
+                <a:solidFill>
+                  <a:srgbClr val="0B2A4A"/>
+                </a:solidFill>
+              </a:defRPr>
+            </a:pPr>
+            <a:r>
+              <a:t>■  M2 — dynamic, regime-aware meta-label (logistic regression):</a:t>
+            </a:r>
+          </a:p>
+          <a:p>
+            <a:pPr lvl="1">
+              <a:spcAft>
+                <a:spcPts val="500"/>
+              </a:spcAft>
+              <a:defRPr sz="1400" b="0">
+                <a:solidFill>
+                  <a:srgbClr val="555B66"/>
+                </a:solidFill>
+              </a:defRPr>
+            </a:pPr>
+            <a:r>
+              <a:t>–  sees momentum, trend, macro, volatility separately + regime features</a:t>
+            </a:r>
+          </a:p>
+          <a:p>
+            <a:pPr lvl="1">
+              <a:spcAft>
+                <a:spcPts val="500"/>
+              </a:spcAft>
+              <a:defRPr sz="1400" b="0">
+                <a:solidFill>
+                  <a:srgbClr val="555B66"/>
+                </a:solidFill>
+              </a:defRPr>
+            </a:pPr>
+            <a:r>
+              <a:t>–  weights factors differently across regimes (factor-timing)</a:t>
+            </a:r>
+          </a:p>
+          <a:p>
+            <a:pPr>
+              <a:spcAft>
+                <a:spcPts val="500"/>
+              </a:spcAft>
+              <a:defRPr sz="1700" b="1">
+                <a:solidFill>
+                  <a:srgbClr val="0B2A4A"/>
+                </a:solidFill>
+              </a:defRPr>
+            </a:pPr>
+            <a:r>
+              <a:t>■  Portfolio — benchmark-relative active weights, vol targeting, position caps, 2-layer costs.</a:t>
+            </a:r>
+          </a:p>
+          <a:p>
+            <a:pPr>
+              <a:spcAft>
+                <a:spcPts val="500"/>
+              </a:spcAft>
+              <a:defRPr sz="1700" b="1">
+                <a:solidFill>
+                  <a:srgbClr val="0B2A4A"/>
+                </a:solidFill>
+              </a:defRPr>
+            </a:pPr>
+            <a:r>
+              <a:t>■  Discipline — no look-ahead, 4-week macro lag, 4-week train/test embargo.</a:t>
+            </a:r>
+          </a:p>
+        </p:txBody>
+      </p:sp>
+      <p:sp>
+        <p:nvSpPr>
+          <p:cNvPr id="6" name="Rectangle 5"/>
+          <p:cNvSpPr/>
+          <p:nvPr/>
+        </p:nvSpPr>
+        <p:spPr>
+          <a:xfrm>
+            <a:off x="548640" y="5715000"/>
+            <a:ext cx="11091672" cy="566928"/>
+          </a:xfrm>
+          <a:prstGeom prst="rect">
+            <a:avLst/>
+          </a:prstGeom>
+          <a:solidFill>
+            <a:srgbClr val="ECF1F6"/>
+          </a:solidFill>
+          <a:ln>
+            <a:noFill/>
+          </a:ln>
+          <a:effectLst/>
+        </p:spPr>
+        <p:style>
+          <a:lnRef idx="1">
+            <a:schemeClr val="accent1"/>
+          </a:lnRef>
+          <a:fillRef idx="3">
+            <a:schemeClr val="accent1"/>
+          </a:fillRef>
+          <a:effectRef idx="2">
+            <a:schemeClr val="accent1"/>
+          </a:effectRef>
+          <a:fontRef idx="minor">
+            <a:schemeClr val="lt1"/>
+          </a:fontRef>
+        </p:style>
+        <p:txBody>
+          <a:bodyPr rtlCol="0" anchor="ctr"/>
+          <a:lstStyle/>
+          <a:p>
+            <a:pPr algn="ctr"/>
+          </a:p>
+        </p:txBody>
+      </p:sp>
+      <p:sp>
+        <p:nvSpPr>
+          <p:cNvPr id="7" name="TextBox 6"/>
+          <p:cNvSpPr txBox="1"/>
+          <p:nvPr/>
+        </p:nvSpPr>
+        <p:spPr>
+          <a:xfrm>
+            <a:off x="731520" y="5760720"/>
+            <a:ext cx="10789920" cy="502920"/>
+          </a:xfrm>
+          <a:prstGeom prst="rect">
+            <a:avLst/>
+          </a:prstGeom>
+          <a:noFill/>
+        </p:spPr>
+        <p:txBody>
+          <a:bodyPr wrap="square" anchor="ctr">
+            <a:spAutoFit/>
+          </a:bodyPr>
+          <a:lstStyle/>
+          <a:p>
+            <a:pPr>
+              <a:defRPr sz="1300" b="1">
+                <a:solidFill>
+                  <a:srgbClr val="1F6FB2"/>
+                </a:solidFill>
+              </a:defRPr>
+            </a:pPr>
+            <a:r>
+              <a:t>Takeaway:  M1 is simple on purpose; all dynamic / regime intelligence is isolated in M2.</a:t>
+            </a:r>
+          </a:p>
+        </p:txBody>
+      </p:sp>
+      <p:sp>
+        <p:nvSpPr>
+          <p:cNvPr id="8" name="TextBox 7"/>
+          <p:cNvSpPr txBox="1"/>
+          <p:nvPr/>
+        </p:nvSpPr>
+        <p:spPr>
+          <a:xfrm>
+            <a:off x="548640" y="6419088"/>
+            <a:ext cx="11155680" cy="320040"/>
+          </a:xfrm>
+          <a:prstGeom prst="rect">
+            <a:avLst/>
+          </a:prstGeom>
+          <a:noFill/>
+        </p:spPr>
+        <p:txBody>
+          <a:bodyPr wrap="square">
+            <a:spAutoFit/>
+          </a:bodyPr>
+          <a:lstStyle/>
+          <a:p>
+            <a:pPr>
+              <a:defRPr sz="900">
+                <a:solidFill>
+                  <a:srgbClr val="555B66"/>
+                </a:solidFill>
+              </a:defRPr>
+            </a:pPr>
+            <a:r>
+              <a:t>Multi-Asset Meta-Labeling  ·  June 18, 2026</a:t>
+            </a:r>
+          </a:p>
+        </p:txBody>
+      </p:sp>
+      <p:sp>
+        <p:nvSpPr>
+          <p:cNvPr id="9" name="TextBox 8"/>
+          <p:cNvSpPr txBox="1"/>
+          <p:nvPr/>
+        </p:nvSpPr>
+        <p:spPr>
+          <a:xfrm>
+            <a:off x="11338560" y="6419088"/>
+            <a:ext cx="640080" cy="320040"/>
+          </a:xfrm>
+          <a:prstGeom prst="rect">
+            <a:avLst/>
+          </a:prstGeom>
+          <a:noFill/>
+        </p:spPr>
+        <p:txBody>
+          <a:bodyPr wrap="square">
+            <a:spAutoFit/>
+          </a:bodyPr>
+          <a:lstStyle/>
+          <a:p>
+            <a:pPr>
+              <a:defRPr sz="900">
+                <a:solidFill>
+                  <a:srgbClr val="555B66"/>
+                </a:solidFill>
+              </a:defRPr>
+            </a:pPr>
+            <a:r>
+              <a:t>3</a:t>
+            </a:r>
+          </a:p>
+        </p:txBody>
+      </p:sp>
+    </p:spTree>
+  </p:cSld>
+  <p:clrMapOvr>
+    <a:masterClrMapping/>
+  </p:clrMapOvr>
+</p:sld>
+</file>
+
+<file path=ppt/slides/slide5.xml><?xml version="1.0" encoding="utf-8"?>
 <p:sld xmlns:a="http://schemas.openxmlformats.org/drawingml/2006/main" xmlns:p="http://schemas.openxmlformats.org/presentationml/2006/main" xmlns:r="http://schemas.openxmlformats.org/officeDocument/2006/relationships">
   <p:cSld>
     <p:spTree>
@@ -6235,7 +7042,7 @@
               </a:defRPr>
             </a:pPr>
             <a:r>
-              <a:t>3</a:t>
+              <a:t>4</a:t>
             </a:r>
           </a:p>
         </p:txBody>
@@ -6248,7 +7055,7 @@
 </p:sld>
 </file>
 
-<file path=ppt/slides/slide5.xml><?xml version="1.0" encoding="utf-8"?>
+<file path=ppt/slides/slide6.xml><?xml version="1.0" encoding="utf-8"?>
 <p:sld xmlns:a="http://schemas.openxmlformats.org/drawingml/2006/main" xmlns:p="http://schemas.openxmlformats.org/presentationml/2006/main" xmlns:r="http://schemas.openxmlformats.org/officeDocument/2006/relationships">
   <p:cSld>
     <p:spTree>
@@ -6623,7 +7430,7 @@
               </a:defRPr>
             </a:pPr>
             <a:r>
-              <a:t>4</a:t>
+              <a:t>5</a:t>
             </a:r>
           </a:p>
         </p:txBody>
@@ -6636,7 +7443,7 @@
 </p:sld>
 </file>
 
-<file path=ppt/slides/slide6.xml><?xml version="1.0" encoding="utf-8"?>
+<file path=ppt/slides/slide7.xml><?xml version="1.0" encoding="utf-8"?>
 <p:sld xmlns:a="http://schemas.openxmlformats.org/drawingml/2006/main" xmlns:p="http://schemas.openxmlformats.org/presentationml/2006/main" xmlns:r="http://schemas.openxmlformats.org/officeDocument/2006/relationships">
   <p:cSld>
     <p:spTree>
@@ -7693,7 +8500,7 @@
               </a:defRPr>
             </a:pPr>
             <a:r>
-              <a:t>5</a:t>
+              <a:t>6</a:t>
             </a:r>
           </a:p>
         </p:txBody>
@@ -7706,7 +8513,7 @@
 </p:sld>
 </file>
 
-<file path=ppt/slides/slide7.xml><?xml version="1.0" encoding="utf-8"?>
+<file path=ppt/slides/slide8.xml><?xml version="1.0" encoding="utf-8"?>
 <p:sld xmlns:a="http://schemas.openxmlformats.org/drawingml/2006/main" xmlns:p="http://schemas.openxmlformats.org/presentationml/2006/main" xmlns:r="http://schemas.openxmlformats.org/officeDocument/2006/relationships">
   <p:cSld>
     <p:spTree>
@@ -8714,7 +9521,7 @@
               </a:defRPr>
             </a:pPr>
             <a:r>
-              <a:t>6</a:t>
+              <a:t>7</a:t>
             </a:r>
           </a:p>
         </p:txBody>
@@ -8727,7 +9534,7 @@
 </p:sld>
 </file>
 
-<file path=ppt/slides/slide8.xml><?xml version="1.0" encoding="utf-8"?>
+<file path=ppt/slides/slide9.xml><?xml version="1.0" encoding="utf-8"?>
 <p:sld xmlns:a="http://schemas.openxmlformats.org/drawingml/2006/main" xmlns:p="http://schemas.openxmlformats.org/presentationml/2006/main" xmlns:r="http://schemas.openxmlformats.org/officeDocument/2006/relationships">
   <p:cSld>
     <p:spTree>
@@ -9433,394 +10240,6 @@
             </a:pPr>
             <a:r>
               <a:t>What it means:  M1's edge over equal-weight is concentrated in 2021+, not uniform. Full-sample numbers flatter M1 than the regime-by-regime view.</a:t>
-            </a:r>
-          </a:p>
-        </p:txBody>
-      </p:sp>
-      <p:sp>
-        <p:nvSpPr>
-          <p:cNvPr id="8" name="TextBox 7"/>
-          <p:cNvSpPr txBox="1"/>
-          <p:nvPr/>
-        </p:nvSpPr>
-        <p:spPr>
-          <a:xfrm>
-            <a:off x="548640" y="6419088"/>
-            <a:ext cx="11155680" cy="320040"/>
-          </a:xfrm>
-          <a:prstGeom prst="rect">
-            <a:avLst/>
-          </a:prstGeom>
-          <a:noFill/>
-        </p:spPr>
-        <p:txBody>
-          <a:bodyPr wrap="square">
-            <a:spAutoFit/>
-          </a:bodyPr>
-          <a:lstStyle/>
-          <a:p>
-            <a:pPr>
-              <a:defRPr sz="900">
-                <a:solidFill>
-                  <a:srgbClr val="555B66"/>
-                </a:solidFill>
-              </a:defRPr>
-            </a:pPr>
-            <a:r>
-              <a:t>Multi-Asset Meta-Labeling  ·  June 18, 2026</a:t>
-            </a:r>
-          </a:p>
-        </p:txBody>
-      </p:sp>
-      <p:sp>
-        <p:nvSpPr>
-          <p:cNvPr id="9" name="TextBox 8"/>
-          <p:cNvSpPr txBox="1"/>
-          <p:nvPr/>
-        </p:nvSpPr>
-        <p:spPr>
-          <a:xfrm>
-            <a:off x="11338560" y="6419088"/>
-            <a:ext cx="640080" cy="320040"/>
-          </a:xfrm>
-          <a:prstGeom prst="rect">
-            <a:avLst/>
-          </a:prstGeom>
-          <a:noFill/>
-        </p:spPr>
-        <p:txBody>
-          <a:bodyPr wrap="square">
-            <a:spAutoFit/>
-          </a:bodyPr>
-          <a:lstStyle/>
-          <a:p>
-            <a:pPr>
-              <a:defRPr sz="900">
-                <a:solidFill>
-                  <a:srgbClr val="555B66"/>
-                </a:solidFill>
-              </a:defRPr>
-            </a:pPr>
-            <a:r>
-              <a:t>7</a:t>
-            </a:r>
-          </a:p>
-        </p:txBody>
-      </p:sp>
-    </p:spTree>
-  </p:cSld>
-  <p:clrMapOvr>
-    <a:masterClrMapping/>
-  </p:clrMapOvr>
-</p:sld>
-</file>
-
-<file path=ppt/slides/slide9.xml><?xml version="1.0" encoding="utf-8"?>
-<p:sld xmlns:a="http://schemas.openxmlformats.org/drawingml/2006/main" xmlns:p="http://schemas.openxmlformats.org/presentationml/2006/main" xmlns:r="http://schemas.openxmlformats.org/officeDocument/2006/relationships">
-  <p:cSld>
-    <p:spTree>
-      <p:nvGrpSpPr>
-        <p:cNvPr id="1" name=""/>
-        <p:cNvGrpSpPr/>
-        <p:nvPr/>
-      </p:nvGrpSpPr>
-      <p:grpSpPr/>
-      <p:sp>
-        <p:nvSpPr>
-          <p:cNvPr id="2" name="Rectangle 1"/>
-          <p:cNvSpPr/>
-          <p:nvPr/>
-        </p:nvSpPr>
-        <p:spPr>
-          <a:xfrm>
-            <a:off x="0" y="0"/>
-            <a:ext cx="201168" cy="6858000"/>
-          </a:xfrm>
-          <a:prstGeom prst="rect">
-            <a:avLst/>
-          </a:prstGeom>
-          <a:solidFill>
-            <a:srgbClr val="0B2A4A"/>
-          </a:solidFill>
-          <a:ln>
-            <a:noFill/>
-          </a:ln>
-          <a:effectLst/>
-        </p:spPr>
-        <p:style>
-          <a:lnRef idx="1">
-            <a:schemeClr val="accent1"/>
-          </a:lnRef>
-          <a:fillRef idx="3">
-            <a:schemeClr val="accent1"/>
-          </a:fillRef>
-          <a:effectRef idx="2">
-            <a:schemeClr val="accent1"/>
-          </a:effectRef>
-          <a:fontRef idx="minor">
-            <a:schemeClr val="lt1"/>
-          </a:fontRef>
-        </p:style>
-        <p:txBody>
-          <a:bodyPr rtlCol="0" anchor="ctr"/>
-          <a:lstStyle/>
-          <a:p>
-            <a:pPr algn="ctr"/>
-          </a:p>
-        </p:txBody>
-      </p:sp>
-      <p:sp>
-        <p:nvSpPr>
-          <p:cNvPr id="3" name="TextBox 2"/>
-          <p:cNvSpPr txBox="1"/>
-          <p:nvPr/>
-        </p:nvSpPr>
-        <p:spPr>
-          <a:xfrm>
-            <a:off x="548640" y="320040"/>
-            <a:ext cx="11338560" cy="822960"/>
-          </a:xfrm>
-          <a:prstGeom prst="rect">
-            <a:avLst/>
-          </a:prstGeom>
-          <a:noFill/>
-        </p:spPr>
-        <p:txBody>
-          <a:bodyPr wrap="square">
-            <a:spAutoFit/>
-          </a:bodyPr>
-          <a:lstStyle/>
-          <a:p>
-            <a:pPr>
-              <a:defRPr sz="2600" b="1">
-                <a:solidFill>
-                  <a:srgbClr val="0B2A4A"/>
-                </a:solidFill>
-              </a:defRPr>
-            </a:pPr>
-            <a:r>
-              <a:t>Key Finding — M2 Does Not Add Value Yet</a:t>
-            </a:r>
-          </a:p>
-        </p:txBody>
-      </p:sp>
-      <p:sp>
-        <p:nvSpPr>
-          <p:cNvPr id="4" name="Rectangle 3"/>
-          <p:cNvSpPr/>
-          <p:nvPr/>
-        </p:nvSpPr>
-        <p:spPr>
-          <a:xfrm>
-            <a:off x="566928" y="1078992"/>
-            <a:ext cx="3840480" cy="41148"/>
-          </a:xfrm>
-          <a:prstGeom prst="rect">
-            <a:avLst/>
-          </a:prstGeom>
-          <a:solidFill>
-            <a:srgbClr val="1F6FB2"/>
-          </a:solidFill>
-          <a:ln>
-            <a:noFill/>
-          </a:ln>
-          <a:effectLst/>
-        </p:spPr>
-        <p:style>
-          <a:lnRef idx="1">
-            <a:schemeClr val="accent1"/>
-          </a:lnRef>
-          <a:fillRef idx="3">
-            <a:schemeClr val="accent1"/>
-          </a:fillRef>
-          <a:effectRef idx="2">
-            <a:schemeClr val="accent1"/>
-          </a:effectRef>
-          <a:fontRef idx="minor">
-            <a:schemeClr val="lt1"/>
-          </a:fontRef>
-        </p:style>
-        <p:txBody>
-          <a:bodyPr rtlCol="0" anchor="ctr"/>
-          <a:lstStyle/>
-          <a:p>
-            <a:pPr algn="ctr"/>
-          </a:p>
-        </p:txBody>
-      </p:sp>
-      <p:sp>
-        <p:nvSpPr>
-          <p:cNvPr id="5" name="TextBox 4"/>
-          <p:cNvSpPr txBox="1"/>
-          <p:nvPr/>
-        </p:nvSpPr>
-        <p:spPr>
-          <a:xfrm>
-            <a:off x="640080" y="1325880"/>
-            <a:ext cx="10972800" cy="4297680"/>
-          </a:xfrm>
-          <a:prstGeom prst="rect">
-            <a:avLst/>
-          </a:prstGeom>
-          <a:noFill/>
-        </p:spPr>
-        <p:txBody>
-          <a:bodyPr wrap="square">
-            <a:spAutoFit/>
-          </a:bodyPr>
-          <a:lstStyle/>
-          <a:p>
-            <a:pPr>
-              <a:spcAft>
-                <a:spcPts val="500"/>
-              </a:spcAft>
-              <a:defRPr sz="1700" b="1">
-                <a:solidFill>
-                  <a:srgbClr val="0B2A4A"/>
-                </a:solidFill>
-              </a:defRPr>
-            </a:pPr>
-            <a:r>
-              <a:t>■  M2's probabilities carry no information — realized success is flat across every predicted bucket:</a:t>
-            </a:r>
-          </a:p>
-          <a:p>
-            <a:pPr lvl="1">
-              <a:spcAft>
-                <a:spcPts val="500"/>
-              </a:spcAft>
-              <a:defRPr sz="1400" b="0">
-                <a:solidFill>
-                  <a:srgbClr val="555B66"/>
-                </a:solidFill>
-              </a:defRPr>
-            </a:pPr>
-            <a:r>
-              <a:t>–  predicted 0.14 → realized 0.44   |   predicted 0.82 → realized 0.43</a:t>
-            </a:r>
-          </a:p>
-          <a:p>
-            <a:pPr>
-              <a:spcAft>
-                <a:spcPts val="500"/>
-              </a:spcAft>
-              <a:defRPr sz="1700" b="1">
-                <a:solidFill>
-                  <a:srgbClr val="0B2A4A"/>
-                </a:solidFill>
-              </a:defRPr>
-            </a:pPr>
-            <a:r>
-              <a:t>■  AUC-ROC = 0.50 full / 0.46 out-of-sample — i.e. random, slightly worse OOS.</a:t>
-            </a:r>
-          </a:p>
-          <a:p>
-            <a:pPr>
-              <a:spcAft>
-                <a:spcPts val="500"/>
-              </a:spcAft>
-              <a:defRPr sz="1700" b="1">
-                <a:solidFill>
-                  <a:srgbClr val="0B2A4A"/>
-                </a:solidFill>
-              </a:defRPr>
-            </a:pPr>
-            <a:r>
-              <a:t>■  M2 underperforms M1-only in every walk-forward window.</a:t>
-            </a:r>
-          </a:p>
-          <a:p>
-            <a:pPr>
-              <a:spcAft>
-                <a:spcPts val="500"/>
-              </a:spcAft>
-              <a:defRPr sz="1700" b="1">
-                <a:solidFill>
-                  <a:srgbClr val="0B2A4A"/>
-                </a:solidFill>
-              </a:defRPr>
-            </a:pPr>
-            <a:r>
-              <a:t>■  Held under both proxy and real macro data — robust, not a tuning artifact.</a:t>
-            </a:r>
-          </a:p>
-        </p:txBody>
-      </p:sp>
-      <p:sp>
-        <p:nvSpPr>
-          <p:cNvPr id="6" name="Rectangle 5"/>
-          <p:cNvSpPr/>
-          <p:nvPr/>
-        </p:nvSpPr>
-        <p:spPr>
-          <a:xfrm>
-            <a:off x="548640" y="5715000"/>
-            <a:ext cx="11091672" cy="566928"/>
-          </a:xfrm>
-          <a:prstGeom prst="rect">
-            <a:avLst/>
-          </a:prstGeom>
-          <a:solidFill>
-            <a:srgbClr val="ECF1F6"/>
-          </a:solidFill>
-          <a:ln>
-            <a:noFill/>
-          </a:ln>
-          <a:effectLst/>
-        </p:spPr>
-        <p:style>
-          <a:lnRef idx="1">
-            <a:schemeClr val="accent1"/>
-          </a:lnRef>
-          <a:fillRef idx="3">
-            <a:schemeClr val="accent1"/>
-          </a:fillRef>
-          <a:effectRef idx="2">
-            <a:schemeClr val="accent1"/>
-          </a:effectRef>
-          <a:fontRef idx="minor">
-            <a:schemeClr val="lt1"/>
-          </a:fontRef>
-        </p:style>
-        <p:txBody>
-          <a:bodyPr rtlCol="0" anchor="ctr"/>
-          <a:lstStyle/>
-          <a:p>
-            <a:pPr algn="ctr"/>
-          </a:p>
-        </p:txBody>
-      </p:sp>
-      <p:sp>
-        <p:nvSpPr>
-          <p:cNvPr id="7" name="TextBox 6"/>
-          <p:cNvSpPr txBox="1"/>
-          <p:nvPr/>
-        </p:nvSpPr>
-        <p:spPr>
-          <a:xfrm>
-            <a:off x="731520" y="5760720"/>
-            <a:ext cx="10789920" cy="502920"/>
-          </a:xfrm>
-          <a:prstGeom prst="rect">
-            <a:avLst/>
-          </a:prstGeom>
-          <a:noFill/>
-        </p:spPr>
-        <p:txBody>
-          <a:bodyPr wrap="square" anchor="ctr">
-            <a:spAutoFit/>
-          </a:bodyPr>
-          <a:lstStyle/>
-          <a:p>
-            <a:pPr>
-              <a:defRPr sz="1300" b="1">
-                <a:solidFill>
-                  <a:srgbClr val="1F6FB2"/>
-                </a:solidFill>
-              </a:defRPr>
-            </a:pPr>
-            <a:r>
-              <a:t>Takeaway:  The meta-label as specified (per-asset, 4-week, benchmark-relative) extracts no conditional signal.</a:t>
             </a:r>
           </a:p>
         </p:txBody>

</xml_diff>